<commit_message>
docs: set explicit image alt text in the presentation deck
Removes build-machine file paths that pptxgenjs was embedding as image
descriptions.
</commit_message>
<xml_diff>
--- a/docs/World-Cup-Analytics-Presentation.pptx
+++ b/docs/World-Cup-Analytics-Presentation.pptx
@@ -2334,7 +2334,7 @@
       </p:sp>
       <p:pic>
         <p:nvPicPr>
-          <p:cNvPr id="13" name="Image 0" descr="/private/tmp/claude-501/-Users-majeedkhan2005-SWE-Endsem-Project/f280e148-7bbf-440e-bf6e-8ea00252318d/scratchpad/shots/dashboard.png">    </p:cNvPr>
+          <p:cNvPr id="13" name="Image 0" descr="World Cup Analytics dashboard">    </p:cNvPr>
           <p:cNvPicPr>
             <a:picLocks noChangeAspect="1"/>
           </p:cNvPicPr>
@@ -17052,7 +17052,7 @@
       </p:sp>
       <p:pic>
         <p:nvPicPr>
-          <p:cNvPr id="5" name="Image 0" descr="/private/tmp/claude-501/-Users-majeedkhan2005-SWE-Endsem-Project/f280e148-7bbf-440e-bf6e-8ea00252318d/scratchpad/shots/predict.png">    </p:cNvPr>
+          <p:cNvPr id="5" name="Image 0" descr="Match predictor page">    </p:cNvPr>
           <p:cNvPicPr>
             <a:picLocks noChangeAspect="1"/>
           </p:cNvPicPr>
@@ -17122,7 +17122,7 @@
       </p:sp>
       <p:pic>
         <p:nvPicPr>
-          <p:cNvPr id="7" name="Image 1" descr="/private/tmp/claude-501/-Users-majeedkhan2005-SWE-Endsem-Project/f280e148-7bbf-440e-bf6e-8ea00252318d/scratchpad/shots/team.png">    </p:cNvPr>
+          <p:cNvPr id="7" name="Image 1" descr="Team explorer page">    </p:cNvPr>
           <p:cNvPicPr>
             <a:picLocks noChangeAspect="1"/>
           </p:cNvPicPr>
@@ -17153,7 +17153,7 @@
       </p:pic>
       <p:pic>
         <p:nvPicPr>
-          <p:cNvPr id="8" name="Image 2" descr="/private/tmp/claude-501/-Users-majeedkhan2005-SWE-Endsem-Project/f280e148-7bbf-440e-bf6e-8ea00252318d/scratchpad/shots/rankings.png">    </p:cNvPr>
+          <p:cNvPr id="8" name="Image 2" descr="Elo world rankings page">    </p:cNvPr>
           <p:cNvPicPr>
             <a:picLocks noChangeAspect="1"/>
           </p:cNvPicPr>

</xml_diff>